<commit_message>
Data Sci App Script
</commit_message>
<xml_diff>
--- a/Final/presentation.pptx
+++ b/Final/presentation.pptx
@@ -311,7 +311,7 @@
           <a:p>
             <a:fld id="{5BCAD085-E8A6-8845-BD4E-CB4CCA059FC4}" type="datetimeFigureOut">
               <a:rPr lang="en-US" smtClean="0"/>
-              <a:t>2/27/2026</a:t>
+              <a:t>3/2/2026</a:t>
             </a:fld>
             <a:endParaRPr lang="en-US"/>
           </a:p>
@@ -479,7 +479,7 @@
           <a:p>
             <a:fld id="{5BCAD085-E8A6-8845-BD4E-CB4CCA059FC4}" type="datetimeFigureOut">
               <a:rPr lang="en-US" smtClean="0"/>
-              <a:t>2/27/2026</a:t>
+              <a:t>3/2/2026</a:t>
             </a:fld>
             <a:endParaRPr lang="en-US"/>
           </a:p>
@@ -657,7 +657,7 @@
           <a:p>
             <a:fld id="{5BCAD085-E8A6-8845-BD4E-CB4CCA059FC4}" type="datetimeFigureOut">
               <a:rPr lang="en-US" smtClean="0"/>
-              <a:t>2/27/2026</a:t>
+              <a:t>3/2/2026</a:t>
             </a:fld>
             <a:endParaRPr lang="en-US"/>
           </a:p>
@@ -825,7 +825,7 @@
           <a:p>
             <a:fld id="{5BCAD085-E8A6-8845-BD4E-CB4CCA059FC4}" type="datetimeFigureOut">
               <a:rPr lang="en-US" smtClean="0"/>
-              <a:t>2/27/2026</a:t>
+              <a:t>3/2/2026</a:t>
             </a:fld>
             <a:endParaRPr lang="en-US"/>
           </a:p>
@@ -1070,7 +1070,7 @@
           <a:p>
             <a:fld id="{5BCAD085-E8A6-8845-BD4E-CB4CCA059FC4}" type="datetimeFigureOut">
               <a:rPr lang="en-US" smtClean="0"/>
-              <a:t>2/27/2026</a:t>
+              <a:t>3/2/2026</a:t>
             </a:fld>
             <a:endParaRPr lang="en-US"/>
           </a:p>
@@ -1355,7 +1355,7 @@
           <a:p>
             <a:fld id="{5BCAD085-E8A6-8845-BD4E-CB4CCA059FC4}" type="datetimeFigureOut">
               <a:rPr lang="en-US" smtClean="0"/>
-              <a:t>2/27/2026</a:t>
+              <a:t>3/2/2026</a:t>
             </a:fld>
             <a:endParaRPr lang="en-US"/>
           </a:p>
@@ -1774,7 +1774,7 @@
           <a:p>
             <a:fld id="{5BCAD085-E8A6-8845-BD4E-CB4CCA059FC4}" type="datetimeFigureOut">
               <a:rPr lang="en-US" smtClean="0"/>
-              <a:t>2/27/2026</a:t>
+              <a:t>3/2/2026</a:t>
             </a:fld>
             <a:endParaRPr lang="en-US"/>
           </a:p>
@@ -1891,7 +1891,7 @@
           <a:p>
             <a:fld id="{5BCAD085-E8A6-8845-BD4E-CB4CCA059FC4}" type="datetimeFigureOut">
               <a:rPr lang="en-US" smtClean="0"/>
-              <a:t>2/27/2026</a:t>
+              <a:t>3/2/2026</a:t>
             </a:fld>
             <a:endParaRPr lang="en-US"/>
           </a:p>
@@ -1986,7 +1986,7 @@
           <a:p>
             <a:fld id="{5BCAD085-E8A6-8845-BD4E-CB4CCA059FC4}" type="datetimeFigureOut">
               <a:rPr lang="en-US" smtClean="0"/>
-              <a:t>2/27/2026</a:t>
+              <a:t>3/2/2026</a:t>
             </a:fld>
             <a:endParaRPr lang="en-US"/>
           </a:p>
@@ -2261,7 +2261,7 @@
           <a:p>
             <a:fld id="{5BCAD085-E8A6-8845-BD4E-CB4CCA059FC4}" type="datetimeFigureOut">
               <a:rPr lang="en-US" smtClean="0"/>
-              <a:t>2/27/2026</a:t>
+              <a:t>3/2/2026</a:t>
             </a:fld>
             <a:endParaRPr lang="en-US"/>
           </a:p>
@@ -2513,7 +2513,7 @@
           <a:p>
             <a:fld id="{5BCAD085-E8A6-8845-BD4E-CB4CCA059FC4}" type="datetimeFigureOut">
               <a:rPr lang="en-US" smtClean="0"/>
-              <a:t>2/27/2026</a:t>
+              <a:t>3/2/2026</a:t>
             </a:fld>
             <a:endParaRPr lang="en-US"/>
           </a:p>
@@ -2724,7 +2724,7 @@
           <a:p>
             <a:fld id="{5BCAD085-E8A6-8845-BD4E-CB4CCA059FC4}" type="datetimeFigureOut">
               <a:rPr lang="en-US" smtClean="0"/>
-              <a:t>2/27/2026</a:t>
+              <a:t>3/2/2026</a:t>
             </a:fld>
             <a:endParaRPr lang="en-US"/>
           </a:p>
@@ -3369,7 +3369,7 @@
         <p:spPr>
           <a:xfrm>
             <a:off x="640080" y="1737360"/>
-            <a:ext cx="10972800" cy="1828800"/>
+            <a:ext cx="10972800" cy="1246495"/>
           </a:xfrm>
           <a:prstGeom prst="rect">
             <a:avLst/>
@@ -3394,7 +3394,16 @@
               </a:defRPr>
             </a:pPr>
             <a:r>
-              <a:t>1. Multi-modal integration of scRNA-seq + TCR-seq for immunotherapy response prediction</a:t>
+              <a:rPr dirty="0"/>
+              <a:t>1. Multi-modal integration of </a:t>
+            </a:r>
+            <a:r>
+              <a:rPr dirty="0" err="1"/>
+              <a:t>scRNA</a:t>
+            </a:r>
+            <a:r>
+              <a:rPr dirty="0"/>
+              <a:t>-seq + TCR-seq for immunotherapy response prediction</a:t>
             </a:r>
           </a:p>
           <a:p>
@@ -3410,7 +3419,16 @@
               </a:defRPr>
             </a:pPr>
             <a:r>
-              <a:t>2. Novel feature engineering: k-mer encoding + physicochemical properties of TCR CDR3 sequences</a:t>
+              <a:rPr dirty="0"/>
+              <a:t>2. Novel feature engineering: k-</a:t>
+            </a:r>
+            <a:r>
+              <a:rPr dirty="0" err="1"/>
+              <a:t>mer</a:t>
+            </a:r>
+            <a:r>
+              <a:rPr dirty="0"/>
+              <a:t> encoding + physicochemical properties of TCR CDR3 sequences</a:t>
             </a:r>
           </a:p>
           <a:p>
@@ -3426,6 +3444,7 @@
               </a:defRPr>
             </a:pPr>
             <a:r>
+              <a:rPr dirty="0"/>
               <a:t>3. Rigorous LOPO validation prevents data leakage in small-cohort clinical trial data</a:t>
             </a:r>
           </a:p>
@@ -3442,7 +3461,24 @@
               </a:defRPr>
             </a:pPr>
             <a:r>
-              <a:t>4. XGBoost achieves best AUC=0.80 — demonstrates feasibility of pre-treatment prediction</a:t>
+              <a:rPr dirty="0"/>
+              <a:t>4. </a:t>
+            </a:r>
+            <a:r>
+              <a:rPr dirty="0" err="1"/>
+              <a:t>XGBoost</a:t>
+            </a:r>
+            <a:r>
+              <a:rPr dirty="0"/>
+              <a:t> achieves best AUC=0.80</a:t>
+            </a:r>
+            <a:r>
+              <a:rPr lang="en-US" dirty="0"/>
+              <a:t>,</a:t>
+            </a:r>
+            <a:r>
+              <a:rPr dirty="0"/>
+              <a:t> demonstrates feasibility of pre-treatment prediction</a:t>
             </a:r>
           </a:p>
         </p:txBody>
@@ -4527,7 +4563,7 @@
         <p:spPr>
           <a:xfrm>
             <a:off x="640080" y="4389120"/>
-            <a:ext cx="10972800" cy="1828800"/>
+            <a:ext cx="10972800" cy="815608"/>
           </a:xfrm>
           <a:prstGeom prst="rect">
             <a:avLst/>
@@ -4552,7 +4588,24 @@
               </a:defRPr>
             </a:pPr>
             <a:r>
-              <a:t>15 Gene Expression PCA  +  50 TRA k-mer SVD  +  50 TRB k-mer SVD  +  6 Physicochemical  +  3 QC Metrics  +  14 Enhanced Physicochemical  +  6 Diversity Metrics</a:t>
+              <a:rPr dirty="0"/>
+              <a:t>15 Gene Expression PCA  +  50 TRA k-</a:t>
+            </a:r>
+            <a:r>
+              <a:rPr dirty="0" err="1"/>
+              <a:t>mer</a:t>
+            </a:r>
+            <a:r>
+              <a:rPr dirty="0"/>
+              <a:t> SVD  +  50 TRB k-</a:t>
+            </a:r>
+            <a:r>
+              <a:rPr dirty="0" err="1"/>
+              <a:t>mer</a:t>
+            </a:r>
+            <a:r>
+              <a:rPr dirty="0"/>
+              <a:t> SVD  +  6 Physicochemical  +  3 QC Metrics  +  14 Enhanced Physicochemical  +  6 Diversity Metrics</a:t>
             </a:r>
           </a:p>
           <a:p>
@@ -4568,7 +4621,16 @@
               </a:defRPr>
             </a:pPr>
             <a:r>
-              <a:t>Validation: Leave-One-Patient-Out (LOPO) — completely prevents data leakage between patients</a:t>
+              <a:rPr dirty="0"/>
+              <a:t>Validation: Leave-One-Patient-Out (LOPO)</a:t>
+            </a:r>
+            <a:r>
+              <a:rPr lang="en-US" dirty="0"/>
+              <a:t>,</a:t>
+            </a:r>
+            <a:r>
+              <a:rPr dirty="0"/>
+              <a:t> completely prevents data leakage between patients</a:t>
             </a:r>
           </a:p>
         </p:txBody>
@@ -5808,7 +5870,7 @@
         <p:spPr>
           <a:xfrm>
             <a:off x="640080" y="4389120"/>
-            <a:ext cx="10972800" cy="1828800"/>
+            <a:ext cx="10972800" cy="1246495"/>
           </a:xfrm>
           <a:prstGeom prst="rect">
             <a:avLst/>
@@ -5833,7 +5895,40 @@
               </a:defRPr>
             </a:pPr>
             <a:r>
-              <a:t>★ Best config: #2 (Deeper) — max_depth=6, lr=0.05, n_estimators=200</a:t>
+              <a:rPr dirty="0"/>
+              <a:t>★ Best config: #2 (Deeper)</a:t>
+            </a:r>
+            <a:r>
+              <a:rPr lang="en-US" dirty="0"/>
+              <a:t>,</a:t>
+            </a:r>
+            <a:r>
+              <a:rPr dirty="0"/>
+              <a:t> </a:t>
+            </a:r>
+            <a:r>
+              <a:rPr dirty="0" err="1"/>
+              <a:t>max_depth</a:t>
+            </a:r>
+            <a:r>
+              <a:rPr dirty="0"/>
+              <a:t>=6, </a:t>
+            </a:r>
+            <a:r>
+              <a:rPr dirty="0" err="1"/>
+              <a:t>lr</a:t>
+            </a:r>
+            <a:r>
+              <a:rPr dirty="0"/>
+              <a:t>=0.05, </a:t>
+            </a:r>
+            <a:r>
+              <a:rPr dirty="0" err="1"/>
+              <a:t>n_estimators</a:t>
+            </a:r>
+            <a:r>
+              <a:rPr dirty="0"/>
+              <a:t>=200</a:t>
             </a:r>
           </a:p>
           <a:p>
@@ -5849,6 +5944,7 @@
               </a:defRPr>
             </a:pPr>
             <a:r>
+              <a:rPr dirty="0"/>
               <a:t>• Config #3 (Low LR) underfits: too conservative learning rate with high regularization</a:t>
             </a:r>
           </a:p>
@@ -5865,6 +5961,7 @@
               </a:defRPr>
             </a:pPr>
             <a:r>
+              <a:rPr dirty="0"/>
               <a:t>• Shallow models (#1, #4) limited by tree depth for complex multi-modal features</a:t>
             </a:r>
           </a:p>
@@ -5881,7 +5978,16 @@
               </a:defRPr>
             </a:pPr>
             <a:r>
-              <a:t>• GroupKFold inner CV used for all hyperparameter selection to prevent data leakage</a:t>
+              <a:rPr dirty="0"/>
+              <a:t>• </a:t>
+            </a:r>
+            <a:r>
+              <a:rPr dirty="0" err="1"/>
+              <a:t>GroupKFold</a:t>
+            </a:r>
+            <a:r>
+              <a:rPr dirty="0"/>
+              <a:t> inner CV used for all hyperparameter selection to prevent data leakage</a:t>
             </a:r>
           </a:p>
         </p:txBody>
@@ -7989,7 +8095,7 @@
         <p:spPr>
           <a:xfrm>
             <a:off x="640080" y="5212080"/>
-            <a:ext cx="10972800" cy="1371600"/>
+            <a:ext cx="10972800" cy="892552"/>
           </a:xfrm>
           <a:prstGeom prst="rect">
             <a:avLst/>
@@ -8014,7 +8120,16 @@
               </a:defRPr>
             </a:pPr>
             <a:r>
-              <a:t>★ XGBoost with comprehensive features achieves best performance (AUC=0.80, F1=0.75)</a:t>
+              <a:rPr dirty="0"/>
+              <a:t>★ </a:t>
+            </a:r>
+            <a:r>
+              <a:rPr dirty="0" err="1"/>
+              <a:t>XGBoost</a:t>
+            </a:r>
+            <a:r>
+              <a:rPr dirty="0"/>
+              <a:t> with comprehensive features achieves best performance (AUC=0.80, F1=0.75)</a:t>
             </a:r>
           </a:p>
           <a:p>
@@ -8030,7 +8145,16 @@
               </a:defRPr>
             </a:pPr>
             <a:r>
-              <a:t>• Tree-based models outperform deep learning — appropriate for small sample sizes</a:t>
+              <a:rPr dirty="0"/>
+              <a:t>• Tree-based models outperform deep learning</a:t>
+            </a:r>
+            <a:r>
+              <a:rPr lang="en-US" dirty="0"/>
+              <a:t>,</a:t>
+            </a:r>
+            <a:r>
+              <a:rPr dirty="0"/>
+              <a:t> appropriate for small sample sizes</a:t>
             </a:r>
           </a:p>
           <a:p>
@@ -8046,6 +8170,7 @@
               </a:defRPr>
             </a:pPr>
             <a:r>
+              <a:rPr dirty="0"/>
               <a:t>• LOPO ensures zero data leakage between patients → robust generalization estimate</a:t>
             </a:r>
           </a:p>
@@ -9228,7 +9353,7 @@
         <p:spPr>
           <a:xfrm>
             <a:off x="640080" y="1737360"/>
-            <a:ext cx="5303520" cy="4114800"/>
+            <a:ext cx="5303520" cy="2939266"/>
           </a:xfrm>
           <a:prstGeom prst="rect">
             <a:avLst/>
@@ -9253,7 +9378,16 @@
               </a:defRPr>
             </a:pPr>
             <a:r>
-              <a:t>1.  TRA_kmer_12  — α-chain CDR3 sequence pattern</a:t>
+              <a:rPr dirty="0"/>
+              <a:t>1.  TRA_kmer_12 </a:t>
+            </a:r>
+            <a:r>
+              <a:rPr lang="en-US" dirty="0"/>
+              <a:t>,</a:t>
+            </a:r>
+            <a:r>
+              <a:rPr dirty="0"/>
+              <a:t> α-chain CDR3 sequence pattern</a:t>
             </a:r>
           </a:p>
           <a:p>
@@ -9269,7 +9403,16 @@
               </a:defRPr>
             </a:pPr>
             <a:r>
-              <a:t>2.  Gene_PC1      — primary expression component</a:t>
+              <a:rPr dirty="0"/>
+              <a:t>2.  Gene_PC1</a:t>
+            </a:r>
+            <a:r>
+              <a:rPr lang="en-US" dirty="0"/>
+              <a:t>,</a:t>
+            </a:r>
+            <a:r>
+              <a:rPr dirty="0"/>
+              <a:t> primary expression component</a:t>
             </a:r>
           </a:p>
           <a:p>
@@ -9285,7 +9428,16 @@
               </a:defRPr>
             </a:pPr>
             <a:r>
-              <a:t>3.  TRB_kmer_5    — β-chain CDR3 motif</a:t>
+              <a:rPr dirty="0"/>
+              <a:t>3.  TRB_kmer_</a:t>
+            </a:r>
+            <a:r>
+              <a:rPr lang="en-US" dirty="0"/>
+              <a:t>5,</a:t>
+            </a:r>
+            <a:r>
+              <a:rPr dirty="0"/>
+              <a:t> β-chain CDR3 motif</a:t>
             </a:r>
           </a:p>
           <a:p>
@@ -9301,7 +9453,16 @@
               </a:defRPr>
             </a:pPr>
             <a:r>
-              <a:t>4.  Gene_PC2      — secondary expression axis</a:t>
+              <a:rPr dirty="0"/>
+              <a:t>4.  Gene_PC2 </a:t>
+            </a:r>
+            <a:r>
+              <a:rPr lang="en-US" dirty="0"/>
+              <a:t>,</a:t>
+            </a:r>
+            <a:r>
+              <a:rPr dirty="0"/>
+              <a:t> secondary expression axis</a:t>
             </a:r>
           </a:p>
           <a:p>
@@ -9317,7 +9478,20 @@
               </a:defRPr>
             </a:pPr>
             <a:r>
-              <a:t>5.  TRA_len        — α-chain CDR3 length</a:t>
+              <a:rPr dirty="0"/>
+              <a:t>5.  </a:t>
+            </a:r>
+            <a:r>
+              <a:rPr dirty="0" err="1"/>
+              <a:t>TRA_len</a:t>
+            </a:r>
+            <a:r>
+              <a:rPr lang="en-US" dirty="0"/>
+              <a:t>,</a:t>
+            </a:r>
+            <a:r>
+              <a:rPr dirty="0"/>
+              <a:t> α-chain CDR3 length</a:t>
             </a:r>
           </a:p>
           <a:p>
@@ -9333,7 +9507,24 @@
               </a:defRPr>
             </a:pPr>
             <a:r>
-              <a:t>6.  TRB_kmer_18  — β-chain k-mer frequency</a:t>
+              <a:rPr dirty="0"/>
+              <a:t>6.  TRB_kmer_18</a:t>
+            </a:r>
+            <a:r>
+              <a:rPr lang="en-US" dirty="0"/>
+              <a:t>,</a:t>
+            </a:r>
+            <a:r>
+              <a:rPr dirty="0"/>
+              <a:t> β-chain k-</a:t>
+            </a:r>
+            <a:r>
+              <a:rPr dirty="0" err="1"/>
+              <a:t>mer</a:t>
+            </a:r>
+            <a:r>
+              <a:rPr dirty="0"/>
+              <a:t> frequency</a:t>
             </a:r>
           </a:p>
           <a:p>
@@ -9349,7 +9540,16 @@
               </a:defRPr>
             </a:pPr>
             <a:r>
-              <a:t>7.  TRB_MW        — β-chain molecular weight</a:t>
+              <a:rPr dirty="0"/>
+              <a:t>7.  TRB_MW</a:t>
+            </a:r>
+            <a:r>
+              <a:rPr lang="en-US" dirty="0"/>
+              <a:t>,</a:t>
+            </a:r>
+            <a:r>
+              <a:rPr dirty="0"/>
+              <a:t> β-chain molecular weight</a:t>
             </a:r>
           </a:p>
           <a:p>
@@ -9365,7 +9565,16 @@
               </a:defRPr>
             </a:pPr>
             <a:r>
-              <a:t>8.  Gene_PC3      — immune activation component</a:t>
+              <a:rPr dirty="0"/>
+              <a:t>8.  Gene_PC3</a:t>
+            </a:r>
+            <a:r>
+              <a:rPr lang="en-US" dirty="0"/>
+              <a:t>,</a:t>
+            </a:r>
+            <a:r>
+              <a:rPr dirty="0"/>
+              <a:t> immune activation component</a:t>
             </a:r>
           </a:p>
           <a:p>
@@ -9381,7 +9590,20 @@
               </a:defRPr>
             </a:pPr>
             <a:r>
-              <a:t>9.  TRA_hydro     — α-chain hydrophobicity</a:t>
+              <a:rPr dirty="0"/>
+              <a:t>9.  </a:t>
+            </a:r>
+            <a:r>
+              <a:rPr dirty="0" err="1"/>
+              <a:t>TRA_hydro</a:t>
+            </a:r>
+            <a:r>
+              <a:rPr lang="en-US" dirty="0"/>
+              <a:t>,</a:t>
+            </a:r>
+            <a:r>
+              <a:rPr dirty="0"/>
+              <a:t> α-chain hydrophobicity</a:t>
             </a:r>
           </a:p>
           <a:p>
@@ -9397,7 +9619,30 @@
               </a:defRPr>
             </a:pPr>
             <a:r>
-              <a:t>10. pct_mt          — mitochondrial gene fraction (QC)</a:t>
+              <a:rPr dirty="0"/>
+              <a:t>10. </a:t>
+            </a:r>
+            <a:r>
+              <a:rPr dirty="0" err="1"/>
+              <a:t>pct</a:t>
+            </a:r>
+            <a:r>
+              <a:rPr err="1"/>
+              <a:t>_</a:t>
+            </a:r>
+            <a:r>
+              <a:t>mt</a:t>
+            </a:r>
+            <a:r>
+              <a:rPr lang="en-US"/>
+              <a:t>,</a:t>
+            </a:r>
+            <a:r>
+              <a:t> </a:t>
+            </a:r>
+            <a:r>
+              <a:rPr dirty="0"/>
+              <a:t>mitochondrial gene fraction (QC)</a:t>
             </a:r>
           </a:p>
         </p:txBody>
@@ -9447,7 +9692,7 @@
         <p:spPr>
           <a:xfrm>
             <a:off x="6400800" y="1737360"/>
-            <a:ext cx="5303520" cy="4114800"/>
+            <a:ext cx="5303520" cy="3524042"/>
           </a:xfrm>
           <a:prstGeom prst="rect">
             <a:avLst/>
@@ -9472,6 +9717,7 @@
               </a:defRPr>
             </a:pPr>
             <a:r>
+              <a:rPr dirty="0"/>
               <a:t>TCR Sequence Features (60% of top 20):</a:t>
             </a:r>
           </a:p>
@@ -9488,7 +9734,16 @@
               </a:defRPr>
             </a:pPr>
             <a:r>
-              <a:t>  → K-mer patterns capture antigen recognition specificity</a:t>
+              <a:rPr dirty="0"/>
+              <a:t>  → K-</a:t>
+            </a:r>
+            <a:r>
+              <a:rPr dirty="0" err="1"/>
+              <a:t>mer</a:t>
+            </a:r>
+            <a:r>
+              <a:rPr dirty="0"/>
+              <a:t> patterns capture antigen recognition specificity</a:t>
             </a:r>
           </a:p>
           <a:p>
@@ -9504,6 +9759,7 @@
               </a:defRPr>
             </a:pPr>
             <a:r>
+              <a:rPr dirty="0"/>
               <a:t>  → CDR3 length variation reflects V(D)J recombination diversity</a:t>
             </a:r>
           </a:p>
@@ -9520,6 +9776,7 @@
               </a:defRPr>
             </a:pPr>
             <a:r>
+              <a:rPr dirty="0"/>
               <a:t>  → Physicochemical properties determine binding affinity</a:t>
             </a:r>
           </a:p>
@@ -9535,7 +9792,7 @@
                 <a:latin typeface="Calibri"/>
               </a:defRPr>
             </a:pPr>
-            <a:endParaRPr/>
+            <a:endParaRPr dirty="0"/>
           </a:p>
           <a:p>
             <a:pPr>
@@ -9550,6 +9807,7 @@
               </a:defRPr>
             </a:pPr>
             <a:r>
+              <a:rPr dirty="0"/>
               <a:t>Gene Expression PCs (30% of top 20):</a:t>
             </a:r>
           </a:p>
@@ -9566,6 +9824,7 @@
               </a:defRPr>
             </a:pPr>
             <a:r>
+              <a:rPr dirty="0"/>
               <a:t>  → PC1/PC2 capture immune activation vs. quiescence axis</a:t>
             </a:r>
           </a:p>
@@ -9582,6 +9841,7 @@
               </a:defRPr>
             </a:pPr>
             <a:r>
+              <a:rPr dirty="0"/>
               <a:t>  → Cytotoxic T-cell signatures correlate with response</a:t>
             </a:r>
           </a:p>
@@ -9597,7 +9857,7 @@
                 <a:latin typeface="Calibri"/>
               </a:defRPr>
             </a:pPr>
-            <a:endParaRPr/>
+            <a:endParaRPr dirty="0"/>
           </a:p>
           <a:p>
             <a:pPr>
@@ -9612,6 +9872,7 @@
               </a:defRPr>
             </a:pPr>
             <a:r>
+              <a:rPr dirty="0"/>
               <a:t>QC Metrics (10% of top 20):</a:t>
             </a:r>
           </a:p>
@@ -9628,6 +9889,7 @@
               </a:defRPr>
             </a:pPr>
             <a:r>
+              <a:rPr dirty="0"/>
               <a:t>  → Mitochondrial fraction may indicate cell stress/apoptosis</a:t>
             </a:r>
           </a:p>
@@ -9644,7 +9906,16 @@
               </a:defRPr>
             </a:pPr>
             <a:r>
-              <a:t>  → Acts as confound indicator—model appropriately learned its role</a:t>
+              <a:rPr dirty="0"/>
+              <a:t>  → Acts as confound indicator</a:t>
+            </a:r>
+            <a:r>
+              <a:rPr lang="en-US" dirty="0"/>
+              <a:t>, </a:t>
+            </a:r>
+            <a:r>
+              <a:rPr dirty="0"/>
+              <a:t>model appropriately learned its role</a:t>
             </a:r>
           </a:p>
         </p:txBody>

</xml_diff>